<commit_message>
feat: deadline-aware alerts, indexed disruptions, a11y fixes, CSV export, manifest, privacy, field kit docs, pilot plan, scorecard; Maharashtra Zone corrections; deck + screenshots
</commit_message>
<xml_diff>
--- a/submission/SafarSetu-Seva-First-Pitch.pptx
+++ b/submission/SafarSetu-Seva-First-Pitch.pptx
@@ -1218,6 +1218,54 @@
           </a:p>
         </p:txBody>
       </p:sp>
+      <p:pic>
+        <p:nvPicPr>
+          <p:cNvPr id="5" name="Picture 4" descr="hero.png"/>
+          <p:cNvPicPr>
+            <a:picLocks noChangeAspect="1"/>
+          </p:cNvPicPr>
+          <p:nvPr/>
+        </p:nvPicPr>
+        <p:blipFill>
+          <a:blip r:embed="rId3"/>
+          <a:stretch>
+            <a:fillRect/>
+          </a:stretch>
+        </p:blipFill>
+        <p:spPr>
+          <a:xfrm>
+            <a:off x="5852160" y="777240"/>
+            <a:ext cx="2834640" cy="1494185"/>
+          </a:xfrm>
+          <a:prstGeom prst="rect">
+            <a:avLst/>
+          </a:prstGeom>
+        </p:spPr>
+      </p:pic>
+      <p:pic>
+        <p:nvPicPr>
+          <p:cNvPr id="6" name="Picture 5" descr="live.png"/>
+          <p:cNvPicPr>
+            <a:picLocks noChangeAspect="1"/>
+          </p:cNvPicPr>
+          <p:nvPr/>
+        </p:nvPicPr>
+        <p:blipFill>
+          <a:blip r:embed="rId4"/>
+          <a:stretch>
+            <a:fillRect/>
+          </a:stretch>
+        </p:blipFill>
+        <p:spPr>
+          <a:xfrm>
+            <a:off x="5852160" y="2386584"/>
+            <a:ext cx="2834639" cy="1401049"/>
+          </a:xfrm>
+          <a:prstGeom prst="rect">
+            <a:avLst/>
+          </a:prstGeom>
+        </p:spPr>
+      </p:pic>
     </p:spTree>
   </p:cSld>
   <p:clrMapOvr>
@@ -5678,7 +5726,7 @@
                 <a:ea typeface="Nirmala UI" pitchFamily="34" charset="-122"/>
                 <a:cs typeface="Nirmala UI" pitchFamily="34" charset="-120"/>
               </a:rPr>
-              <a:t>~10 lakh</a:t>
+              <a:t>3,000</a:t>
             </a:r>
             <a:endParaRPr lang="en-US" sz="3000" dirty="0"/>
           </a:p>
@@ -5756,7 +5804,7 @@
                 <a:ea typeface="Nirmala UI" pitchFamily="34" charset="-122"/>
                 <a:cs typeface="Nirmala UI" pitchFamily="34" charset="-120"/>
               </a:rPr>
-              <a:t>addressable: PMPML riders/day; target TBD</a:t>
+              <a:t>Year-1 pilot target; not a result</a:t>
             </a:r>
             <a:endParaRPr lang="en-US" sz="900" dirty="0"/>
           </a:p>
@@ -5829,7 +5877,7 @@
                 <a:ea typeface="Nirmala UI" pitchFamily="34" charset="-122"/>
                 <a:cs typeface="Nirmala UI" pitchFamily="34" charset="-120"/>
               </a:rPr>
-              <a:t>TBD</a:t>
+              <a:t>~₹980</a:t>
             </a:r>
             <a:endParaRPr lang="en-US" sz="3000" dirty="0"/>
           </a:p>
@@ -5907,7 +5955,7 @@
                 <a:ea typeface="Nirmala UI" pitchFamily="34" charset="-122"/>
                 <a:cs typeface="Nirmala UI" pitchFamily="34" charset="-120"/>
               </a:rPr>
-              <a:t>est. only, cab-baseline model; not measured</a:t>
+              <a:t>est. per work day vs all-cab (model)</a:t>
             </a:r>
             <a:endParaRPr lang="en-US" sz="900" dirty="0"/>
           </a:p>
@@ -5980,7 +6028,7 @@
                 <a:ea typeface="Nirmala UI" pitchFamily="34" charset="-122"/>
                 <a:cs typeface="Nirmala UI" pitchFamily="34" charset="-120"/>
               </a:rPr>
-              <a:t>TBD</a:t>
+              <a:t>2 per city</a:t>
             </a:r>
             <a:endParaRPr lang="en-US" sz="3000" dirty="0"/>
           </a:p>
@@ -6058,7 +6106,7 @@
                 <a:ea typeface="Nirmala UI" pitchFamily="34" charset="-122"/>
                 <a:cs typeface="Nirmala UI" pitchFamily="34" charset="-120"/>
               </a:rPr>
-              <a:t>none claimed; data steward planned</a:t>
+              <a:t>data steward + field ambassador (planned)</a:t>
             </a:r>
             <a:endParaRPr lang="en-US" sz="900" dirty="0"/>
           </a:p>
@@ -6170,7 +6218,7 @@
                 <a:ea typeface="Nirmala UI" pitchFamily="34" charset="-122"/>
                 <a:cs typeface="Nirmala UI" pitchFamily="34" charset="-120"/>
               </a:rPr>
-              <a:t>Fewer missed connections and rushed trips; Gentle pace and late-walk warnings for seniors; citizen gap reports reach authorities. Impact not yet measured.</a:t>
+              <a:t>Marathi/Hindi alerts, Gentle pace and late-walk warnings include seniors and women commuters; shareable live trips; gap reports reach authorities. Impact not yet measured.</a:t>
             </a:r>
             <a:endParaRPr lang="en-US" sz="1000" dirty="0"/>
           </a:p>
@@ -6394,7 +6442,7 @@
                 <a:ea typeface="Nirmala UI" pitchFamily="34" charset="-122"/>
                 <a:cs typeface="Nirmala UI" pitchFamily="34" charset="-120"/>
               </a:rPr>
-              <a:t>A city is a data pack (GTFS + places). Next: Nashik, Nagpur, then other states. Needs agency feeds and a data steward.</a:t>
+              <a:t>1 corridor, 30 users → 5–10 sites, 300 → one depot, 3,000 → 3 cities, 30,000. A city is a data pack (GTFS + places).</a:t>
             </a:r>
             <a:endParaRPr lang="en-US" sz="1000" dirty="0"/>
           </a:p>

</xml_diff>

<commit_message>
round 2: corrected competitor claims, DPDP consent/notice, agency outreach kit, two-page note, evaluator Q&A, scorecard
</commit_message>
<xml_diff>
--- a/submission/SafarSetu-Seva-First-Pitch.pptx
+++ b/submission/SafarSetu-Seva-First-Pitch.pptx
@@ -1593,7 +1593,7 @@
                 <a:ea typeface="Nirmala UI" pitchFamily="34" charset="-122"/>
                 <a:cs typeface="Nirmala UI" pitchFamily="34" charset="-120"/>
               </a:rPr>
-              <a:t>Commuters juggle several apps and learn of delays late. Google Help: no multi-stop directions for public transit. Nobody plans a working day around deadlines.</a:t>
+              <a:t>Commuters juggle several apps and learn of delays late. Google Maps: arrive-by for one transit destination only (Google Help). We found no app that plans a working day around deadlines.</a:t>
             </a:r>
             <a:endParaRPr lang="en-US" sz="1000" dirty="0"/>
           </a:p>
@@ -1929,7 +1929,7 @@
                 <a:ea typeface="Nirmala UI" pitchFamily="34" charset="-122"/>
                 <a:cs typeface="Nirmala UI" pitchFamily="34" charset="-120"/>
               </a:rPr>
-              <a:t>Moovit, m-Indicator and Mumbai One give routes and tickets, not a day of timed stops. We complement agency ITMS, not replace it. Alerts rarely say what to do.</a:t>
+              <a:t>Moovit, m-Indicator, Mumbai One and Google plan single trips; Mumbai One adds tickets and alerts. We complement agency ITMS, not replace it.</a:t>
             </a:r>
             <a:endParaRPr lang="en-US" sz="1000" dirty="0"/>
           </a:p>

</xml_diff>